<commit_message>
feat: hide signup screen behind internal password gate
- Remove public /register route visibility (no link from login page)
- Add RegisterGate component with password protection (sessionStorage unlock)
- /register route now shows a lock screen; correct password reveals signup form
- LoginPage: removed 'Create one free' signup link
</commit_message>
<xml_diff>
--- a/Doott_PitchDeck_UdbhavX2.pptx
+++ b/Doott_PitchDeck_UdbhavX2.pptx
@@ -6076,7 +6076,7 @@
                 </a:solidFill>
                 <a:latin typeface="Calibri"/>
               </a:rPr>
-              <a:t>Doott — One Platform. Entire Sales Pipeline.</a:t>
+              <a:t>Doott — Your B2B Intelligence, Instantly.</a:t>
             </a:r>
           </a:p>
         </p:txBody>
@@ -6111,7 +6111,7 @@
                 </a:solidFill>
                 <a:latin typeface="Calibri"/>
               </a:rPr>
-              <a:t>6-stage autonomous AI pipeline · 10,000 leads/week · zero manual effort</a:t>
+              <a:t>Companies · People · Emails · Numbers · Categories · AI Chatbot — live today</a:t>
             </a:r>
           </a:p>
         </p:txBody>
@@ -6267,7 +6267,7 @@
                 </a:solidFill>
                 <a:latin typeface="Calibri"/>
               </a:rPr>
-              <a:t>🔍  DISCOVER</a:t>
+              <a:t>🏢  COMPANIES</a:t>
             </a:r>
           </a:p>
         </p:txBody>
@@ -6302,8 +6302,8 @@
                 </a:solidFill>
                 <a:latin typeface="Calibri"/>
               </a:rPr>
-              <a:t>Finds companies matching
-your Ideal Customer Profile</a:t>
+              <a:t>Search 1L+ verified
+Indian B2B companies</a:t>
             </a:r>
           </a:p>
         </p:txBody>
@@ -6459,7 +6459,7 @@
                 </a:solidFill>
                 <a:latin typeface="Calibri"/>
               </a:rPr>
-              <a:t>📋  ENRICH</a:t>
+              <a:t>👥  PEOPLE</a:t>
             </a:r>
           </a:p>
         </p:txBody>
@@ -6494,8 +6494,8 @@
                 </a:solidFill>
                 <a:latin typeface="Calibri"/>
               </a:rPr>
-              <a:t>Gets verified emails, phones
-&amp; LinkedIn of decision-makers</a:t>
+              <a:t>Find decision-makers:
+CTOs, VPs, founders</a:t>
             </a:r>
           </a:p>
         </p:txBody>
@@ -6651,7 +6651,7 @@
                 </a:solidFill>
                 <a:latin typeface="Calibri"/>
               </a:rPr>
-              <a:t>✉️  OUTREACH</a:t>
+              <a:t>📧  EMAILS</a:t>
             </a:r>
           </a:p>
         </p:txBody>
@@ -6686,8 +6686,8 @@
                 </a:solidFill>
                 <a:latin typeface="Calibri"/>
               </a:rPr>
-              <a:t>AI writes &amp; sends hyper-
-personalized cold emails</a:t>
+              <a:t>Verified business emails
+ready to use — zero bounces</a:t>
             </a:r>
           </a:p>
         </p:txBody>
@@ -6843,7 +6843,7 @@
                 </a:solidFill>
                 <a:latin typeface="Calibri"/>
               </a:rPr>
-              <a:t>📈  SCORE</a:t>
+              <a:t>📞  NUMBERS</a:t>
             </a:r>
           </a:p>
         </p:txBody>
@@ -6878,8 +6878,8 @@
                 </a:solidFill>
                 <a:latin typeface="Calibri"/>
               </a:rPr>
-              <a:t>AI scores every lead
-0–100 based on ICP fit</a:t>
+              <a:t>Direct-dial phone numbers
+for Indian B2B contacts</a:t>
             </a:r>
           </a:p>
         </p:txBody>
@@ -7035,7 +7035,7 @@
                 </a:solidFill>
                 <a:latin typeface="Calibri"/>
               </a:rPr>
-              <a:t>📊  REPORT</a:t>
+              <a:t>🔲  CATEGORIES</a:t>
             </a:r>
           </a:p>
         </p:txBody>
@@ -7070,8 +7070,8 @@
                 </a:solidFill>
                 <a:latin typeface="Calibri"/>
               </a:rPr>
-              <a:t>Live Google Sheets dashboard
-with full pipeline data</a:t>
+              <a:t>Browse any industry vertical
+to surface targeted leads</a:t>
             </a:r>
           </a:p>
         </p:txBody>
@@ -7227,7 +7227,7 @@
                 </a:solidFill>
                 <a:latin typeface="Calibri"/>
               </a:rPr>
-              <a:t>🤖  CHATBOT</a:t>
+              <a:t>💬  ASK DOOTT</a:t>
             </a:r>
           </a:p>
         </p:txBody>
@@ -7262,8 +7262,8 @@
                 </a:solidFill>
                 <a:latin typeface="Calibri"/>
               </a:rPr>
-              <a:t>RAG AI chatbot answers
-prospect questions 24/7</a:t>
+              <a:t>AI chatbot answers your
+sales questions 24/7</a:t>
             </a:r>
           </a:p>
         </p:txBody>
@@ -7532,7 +7532,7 @@
                 </a:solidFill>
                 <a:latin typeface="Calibri"/>
               </a:rPr>
-              <a:t>Result:  10,000 leads processed per week at the cost of a single SaaS subscription — not ₹10 lakh/year per SDR</a:t>
+              <a:t>⚡  Result: What takes a sales team hours of manual research — Doott surfaces in seconds.</a:t>
             </a:r>
           </a:p>
         </p:txBody>
@@ -14392,7 +14392,7 @@
                 </a:solidFill>
                 <a:latin typeface="Calibri"/>
               </a:rPr>
-              <a:t>15+</a:t>
+              <a:t>6</a:t>
             </a:r>
           </a:p>
         </p:txBody>
@@ -14427,8 +14427,8 @@
                 </a:solidFill>
                 <a:latin typeface="Calibri"/>
               </a:rPr>
-              <a:t>Platform Modules
-Built &amp; Live</a:t>
+              <a:t>Live Features
+In the Product</a:t>
             </a:r>
           </a:p>
         </p:txBody>
@@ -14549,7 +14549,7 @@
                 </a:solidFill>
                 <a:latin typeface="Calibri"/>
               </a:rPr>
-              <a:t>38%</a:t>
+              <a:t>1L+</a:t>
             </a:r>
           </a:p>
         </p:txBody>
@@ -14584,8 +14584,8 @@
                 </a:solidFill>
                 <a:latin typeface="Calibri"/>
               </a:rPr>
-              <a:t>Email Open Rate
-vs 21% industry</a:t>
+              <a:t>Indian B2B Contacts
+Indexed &amp; Verified</a:t>
             </a:r>
           </a:p>
         </p:txBody>
@@ -14741,8 +14741,8 @@
                 </a:solidFill>
                 <a:latin typeface="Calibri"/>
               </a:rPr>
-              <a:t>Autonomous AI
-Agents Running</a:t>
+              <a:t>Live Core Features
+Shipped to Users</a:t>
             </a:r>
           </a:p>
         </p:txBody>
@@ -14941,7 +14941,7 @@
                 </a:solidFill>
                 <a:latin typeface="Calibri"/>
               </a:rPr>
-              <a:t>PRODUCT MILESTONES ACHIEVED</a:t>
+              <a:t>LIVE FEATURES SHIPPED</a:t>
             </a:r>
           </a:p>
         </p:txBody>
@@ -15019,7 +15019,7 @@
                 </a:solidFill>
                 <a:latin typeface="Calibri"/>
               </a:rPr>
-              <a:t>✅  6-Agent AI Pipeline fully operational</a:t>
+              <a:t>✅  Companies &amp; People Database — 1L+ records</a:t>
             </a:r>
           </a:p>
         </p:txBody>
@@ -15097,7 +15097,7 @@
                 </a:solidFill>
                 <a:latin typeface="Calibri"/>
               </a:rPr>
-              <a:t>✅  India B2B Database — 1L+ verified contacts</a:t>
+              <a:t>✅  Verified Emails &amp; Phone Numbers lookup</a:t>
             </a:r>
           </a:p>
         </p:txBody>
@@ -15175,7 +15175,7 @@
                 </a:solidFill>
                 <a:latin typeface="Calibri"/>
               </a:rPr>
-              <a:t>✅  RAG AI Chatbot — knowledge-base powered</a:t>
+              <a:t>✅  Category Explorer — browse by industry vertical</a:t>
             </a:r>
           </a:p>
         </p:txBody>
@@ -15253,7 +15253,7 @@
                 </a:solidFill>
                 <a:latin typeface="Calibri"/>
               </a:rPr>
-              <a:t>✅  Social Media Automation (LinkedIn, IG, X, FB)</a:t>
+              <a:t>✅  Ask Doott AI Chatbot — 24/7 always-on assistant</a:t>
             </a:r>
           </a:p>
         </p:txBody>
@@ -15331,7 +15331,7 @@
                 </a:solidFill>
                 <a:latin typeface="Calibri"/>
               </a:rPr>
-              <a:t>✅  Google Places Scraper — geo-targeted leads</a:t>
+              <a:t>✅  Secure multi-tenant auth (Email + Google OAuth)</a:t>
             </a:r>
           </a:p>
         </p:txBody>
@@ -15409,7 +15409,7 @@
                 </a:solidFill>
                 <a:latin typeface="Calibri"/>
               </a:rPr>
-              <a:t>✅  Multi-tenant CRM — org-level data isolation</a:t>
+              <a:t>✅  Dark/Light mode · Settings · In-app docs</a:t>
             </a:r>
           </a:p>
         </p:txBody>

</xml_diff>